<commit_message>
Clarify planned operating-condition decoupling in architecture flowchart
</commit_message>
<xml_diff>
--- a/docs/汇报/整体架构流程图/电动工具预测性维护_整体架构流程图_可编辑.pptx
+++ b/docs/汇报/整体架构流程图/电动工具预测性维护_整体架构流程图_可编辑.pptx
@@ -503,6 +503,11 @@
           <a:p>
             <a:r>
               <a:t>本图依据发明专利研发任务书整理拟定整体方案，图内模块及算法路线不代表均已在实物工具完成验证。当前公开CWRU模型仍仅为振动故障分类；NASA资料用于趋势探索，多模态与维修流程有独立仿真链路。Transformer–LSTM、蒸馏和线性注意力为拟定模型路线与可选改进，最终选择由数据、对照与部署验证确定。</a:t>
+            </a:r>
+          </a:p>
+          <a:p>
+            <a:r>
+              <a:t>第三步拟开展工况解耦：利用转速和负载信息，减弱工况变化对健康特征的干扰，融合多源特征。当前条件健康参考是原型基础，完整解耦机制及其效果仍需验证。</a:t>
             </a:r>
           </a:p>
         </p:txBody>
@@ -4189,7 +4194,7 @@
                 <a:ea typeface="Microsoft YaHei"/>
                 <a:cs typeface="Microsoft YaHei"/>
               </a:rPr>
-              <a:t>工况处理与融合</a:t>
+              <a:t>工况解耦与融合</a:t>
             </a:r>
           </a:p>
         </p:txBody>
@@ -4236,7 +4241,7 @@
                 <a:ea typeface="Microsoft YaHei"/>
                 <a:cs typeface="Microsoft YaHei"/>
               </a:rPr>
-              <a:t>结合转速／负载</a:t>
+              <a:t>转速／负载作为输入</a:t>
             </a:r>
           </a:p>
           <a:p>
@@ -4260,7 +4265,7 @@
                 <a:ea typeface="Microsoft YaHei"/>
                 <a:cs typeface="Microsoft YaHei"/>
               </a:rPr>
-              <a:t>区分工况与损伤</a:t>
+              <a:t>减弱工况变化干扰</a:t>
             </a:r>
           </a:p>
           <a:p>
@@ -4284,7 +4289,7 @@
                 <a:ea typeface="Microsoft YaHei"/>
                 <a:cs typeface="Microsoft YaHei"/>
               </a:rPr>
-              <a:t>多源融合</a:t>
+              <a:t>融合多源健康特征</a:t>
             </a:r>
           </a:p>
         </p:txBody>

</xml_diff>